<commit_message>
docs: refine AI software development report slides
</commit_message>
<xml_diff>
--- a/docs/report/ai-redefines-software-development-presentation/ai-redefines-software-development.pptx
+++ b/docs/report/ai-redefines-software-development-presentation/ai-redefines-software-development.pptx
@@ -701,8 +701,8 @@
               <a:t>第 11 页：谢谢
 建议时长：Q&amp;A
 页内重点：致谢页，并明确进入答疑互动环节。
-互动提问：欢迎围绕 AI 编程、工程治理和高校教学继续讨论。
-讲稿：以上就是今天的主要内容。最后留一个互动问题：如果 AI 能让个人产能接近一个小团队，团队协作、质量责任和课程评价应该如何重新设计？接下来进入答疑互动，欢迎围绕课程教学、开源协作或企业研发流程继续交流。
+互动提问：围绕 AI 编程、工程治理和开发者角色继续讨论。
+讲稿：以上就是今天的主要内容。最后留一个互动问题：如果 AI 能让个人产能接近一个小团队，团队协作、质量责任和课程评价应该如何重新设计？接下来进入答疑互动，围绕 AI 编程、工程治理和开发者角色继续交流。
 转场：答疑互动。</a:t>
             </a:r>
             <a:endParaRPr lang="en-US" dirty="0"/>
@@ -977,11 +977,11 @@
           <a:p>
             <a:r>
               <a:rPr lang="en-US" dirty="0"/>
-              <a:t>第 4 页：18w+ 行代码之后，问题真的变少了吗？
+              <a:t>第 4 页：xx w+ 行代码之后，问题真的变少了吗？
 建议时长：约 2 分钟
-页内重点：开场案例：用 BitFun 一个月 18w+ 行代码引出产能放大后的工程问题。
-互动提问：如果一个项目一个月写出 18w+ 行代码，我们应该先兴奋，还是先紧张？
-讲稿：先看一个现象：如果一个项目借助 AI，一个月可以产出 18w+ 行代码，我们应该先兴奋，还是先紧张？这里不要把数字讲成产能宣传，而要把它讲成问题入口。代码写得更快，是否意味着产品更快成熟？需求改得更频繁，是否意味着方向更灵活，还是更容易失控？团队协作变少，是否意味着效率更高，还是质量检查被省略？如果进入开源高质量协作或复杂组织交付，还缺什么？这页的核心判断是：AI 首先改变的不是“代码怎么写”，而是软件开发的速度、风险和组织方式如何被重新分配。
+页内重点：开场案例：用 BitFun 一个月 xx w+ 行代码引出产能放大后的工程问题。
+互动提问：如果一个项目一个月写出 xx w+ 行代码，我们应该先兴奋，还是先紧张？
+讲稿：先看一个现象：如果一个项目借助 AI，一个月可以产出 xx w+ 行代码，我们应该先兴奋，还是先紧张？这里不要把数字讲成产能宣传，而要把它讲成问题入口。代码写得更快，是否意味着产品更快成熟？需求改得更频繁，是否意味着方向更灵活，还是更容易失控？团队协作变少，是否意味着效率更高，还是质量检查被省略？如果进入开源高质量协作或复杂组织交付，还缺什么？这页的核心判断是：AI 首先改变的不是“代码怎么写”，而是软件开发的速度、风险和组织方式如何被重新分配。
 转场：接下来先讲 AI 的正面价值：探索变快，变化也变快。</a:t>
             </a:r>
             <a:endParaRPr lang="en-US" dirty="0"/>
@@ -1167,7 +1167,7 @@
 建议时长：约 2 分钟
 页内重点：大纲第 4 页：速度放大之后，解释质量责任、追溯、协作和长期维护缺口。
 互动提问：AI 生成的代码能跑之后，距离可合并、可发布、可长期维护还差什么？
-讲稿：速度放大之后，新的问题会出现。非商用探索阶段，很多问题可以暂时接受：功能能跑，但边界不一定稳定；需求变化很快，但设计决策不一定沉淀；代码很多，但 review 和测试不一定跟上；一个人推进很快，但知识可能没有进入团队流程；Agent 能修问题，但修复依据可能来自模型自信，而不是外部证据。这里也能引出概率性和确定性的关系：AI 生成过程允许多路径探索，但软件工程的放行依据必须是可复现、可审查、可回滚的确定性证据。
+讲稿：速度放大之后，新的问题会出现。非商用探索阶段，很多问题可以暂时接受：功能能跑，但边界不一定稳定；需求变化很快，但设计决策不一定沉淀；代码很多，但评审和测试不一定跟上；一个人推进很快，但知识可能没有进入团队流程；Agent 能修问题，但修复依据可能来自模型自信，而不是外部证据。这里也能引出概率性和确定性的关系：AI 生成过程允许多路径探索，但软件工程的放行依据必须是可复现、可审查、可回滚的确定性证据。
 转场：走出个人探索之后，会出现两类不同的高质量要求。</a:t>
             </a:r>
             <a:endParaRPr lang="en-US" dirty="0"/>

</xml_diff>